<commit_message>
Update ESMO poster 4355P to clinical effectiveness report v3.11
All poster numbers now match reports/clinical_effectiveness.md v3.11 and
Table S2 after #181-#184. The #181 PFS rule gives 50 events (treatment PFS
HR 0.77; CRP x treatment PFS HR 0.26, p = 0.10). The #183 ridge values
are CRP x treatment 0.80 OS / 0.66 PFS and TLR x treatment 1.13 / 0.63.
The TLR landmark uses the shared 65-patient cohort (n = 65 OS, 56 PFS;
landmark TLR PFS HR 0.21).

Key-findings text, Methods (PFS death rule, ridge as a stability check),
Table 1 and footnote are updated, and "target lesion reduction" is used.
The poster DAG has separate Age and Sex nodes, matching the paper's
simplified DAG. The forest axis is widened so that the CRP x treatment
PFS interval is drawn in full, with a stop if an interval leaves the
axis. Checked by rendering through PowerPoint: all text fits its boxes.

Co-Authored-By: Claude Opus 5.5 (1M context) <noreply@anthropic.com>
</commit_message>
<xml_diff>
--- a/outputs/vignettes/poster_ESMO.pptx
+++ b/outputs/vignettes/poster_ESMO.pptx
@@ -110,12 +110,12 @@
   <p:extLst>
     <p:ext uri="{EFAFB233-063F-42B5-8137-9DF3F51BA10A}">
       <p15:sldGuideLst xmlns:p15="http://schemas.microsoft.com/office/powerpoint/2012/main">
-        <p15:guide id="2" pos="206" userDrawn="1">
+        <p15:guide id="2" pos="16101" userDrawn="1">
           <p15:clr>
             <a:srgbClr val="A4A3A4"/>
           </p15:clr>
         </p15:guide>
-        <p15:guide id="3" orient="horz" pos="12322" userDrawn="1">
+        <p15:guide id="3" orient="horz" pos="19255" userDrawn="1">
           <p15:clr>
             <a:srgbClr val="A4A3A4"/>
           </p15:clr>
@@ -208,7 +208,7 @@
           <a:p>
             <a:fld id="{89CEAEC2-C692-4B46-978F-109B22A150D2}" type="datetimeFigureOut">
               <a:rPr lang="en-US" smtClean="0"/>
-              <a:t>9/23/2026</a:t>
+              <a:t>9/18/2026</a:t>
             </a:fld>
             <a:endParaRPr lang="en-US" dirty="0"/>
           </a:p>
@@ -703,7 +703,7 @@
           <a:p>
             <a:fld id="{EDF32165-6009-0A44-BE1F-48670E89FB19}" type="datetimeFigureOut">
               <a:rPr lang="en-US" smtClean="0"/>
-              <a:t>9/23/2026</a:t>
+              <a:t>9/18/2026</a:t>
             </a:fld>
             <a:endParaRPr lang="en-US" dirty="0"/>
           </a:p>
@@ -873,7 +873,7 @@
           <a:p>
             <a:fld id="{EDF32165-6009-0A44-BE1F-48670E89FB19}" type="datetimeFigureOut">
               <a:rPr lang="en-US" smtClean="0"/>
-              <a:t>9/23/2026</a:t>
+              <a:t>9/18/2026</a:t>
             </a:fld>
             <a:endParaRPr lang="en-US" dirty="0"/>
           </a:p>
@@ -1053,7 +1053,7 @@
           <a:p>
             <a:fld id="{EDF32165-6009-0A44-BE1F-48670E89FB19}" type="datetimeFigureOut">
               <a:rPr lang="en-US" smtClean="0"/>
-              <a:t>9/23/2026</a:t>
+              <a:t>9/18/2026</a:t>
             </a:fld>
             <a:endParaRPr lang="en-US" dirty="0"/>
           </a:p>
@@ -1223,7 +1223,7 @@
           <a:p>
             <a:fld id="{EDF32165-6009-0A44-BE1F-48670E89FB19}" type="datetimeFigureOut">
               <a:rPr lang="en-US" smtClean="0"/>
-              <a:t>9/23/2026</a:t>
+              <a:t>9/18/2026</a:t>
             </a:fld>
             <a:endParaRPr lang="en-US" dirty="0"/>
           </a:p>
@@ -1469,7 +1469,7 @@
           <a:p>
             <a:fld id="{EDF32165-6009-0A44-BE1F-48670E89FB19}" type="datetimeFigureOut">
               <a:rPr lang="en-US" smtClean="0"/>
-              <a:t>9/23/2026</a:t>
+              <a:t>9/18/2026</a:t>
             </a:fld>
             <a:endParaRPr lang="en-US" dirty="0"/>
           </a:p>
@@ -1701,7 +1701,7 @@
           <a:p>
             <a:fld id="{EDF32165-6009-0A44-BE1F-48670E89FB19}" type="datetimeFigureOut">
               <a:rPr lang="en-US" smtClean="0"/>
-              <a:t>9/23/2026</a:t>
+              <a:t>9/18/2026</a:t>
             </a:fld>
             <a:endParaRPr lang="en-US" dirty="0"/>
           </a:p>
@@ -2068,7 +2068,7 @@
           <a:p>
             <a:fld id="{EDF32165-6009-0A44-BE1F-48670E89FB19}" type="datetimeFigureOut">
               <a:rPr lang="en-US" smtClean="0"/>
-              <a:t>9/23/2026</a:t>
+              <a:t>9/18/2026</a:t>
             </a:fld>
             <a:endParaRPr lang="en-US" dirty="0"/>
           </a:p>
@@ -2186,7 +2186,7 @@
           <a:p>
             <a:fld id="{EDF32165-6009-0A44-BE1F-48670E89FB19}" type="datetimeFigureOut">
               <a:rPr lang="en-US" smtClean="0"/>
-              <a:t>9/23/2026</a:t>
+              <a:t>9/18/2026</a:t>
             </a:fld>
             <a:endParaRPr lang="en-US" dirty="0"/>
           </a:p>
@@ -2281,7 +2281,7 @@
           <a:p>
             <a:fld id="{EDF32165-6009-0A44-BE1F-48670E89FB19}" type="datetimeFigureOut">
               <a:rPr lang="en-US" smtClean="0"/>
-              <a:t>9/23/2026</a:t>
+              <a:t>9/18/2026</a:t>
             </a:fld>
             <a:endParaRPr lang="en-US" dirty="0"/>
           </a:p>
@@ -2558,7 +2558,7 @@
           <a:p>
             <a:fld id="{EDF32165-6009-0A44-BE1F-48670E89FB19}" type="datetimeFigureOut">
               <a:rPr lang="en-US" smtClean="0"/>
-              <a:t>9/23/2026</a:t>
+              <a:t>9/18/2026</a:t>
             </a:fld>
             <a:endParaRPr lang="en-US" dirty="0"/>
           </a:p>
@@ -2814,7 +2814,7 @@
           <a:p>
             <a:fld id="{EDF32165-6009-0A44-BE1F-48670E89FB19}" type="datetimeFigureOut">
               <a:rPr lang="en-US" smtClean="0"/>
-              <a:t>9/23/2026</a:t>
+              <a:t>9/18/2026</a:t>
             </a:fld>
             <a:endParaRPr lang="en-US" dirty="0"/>
           </a:p>
@@ -3027,7 +3027,7 @@
           <a:p>
             <a:fld id="{EDF32165-6009-0A44-BE1F-48670E89FB19}" type="datetimeFigureOut">
               <a:rPr lang="en-US" smtClean="0"/>
-              <a:t>9/23/2026</a:t>
+              <a:t>9/18/2026</a:t>
             </a:fld>
             <a:endParaRPr lang="en-US" dirty="0"/>
           </a:p>
@@ -3432,30 +3432,6 @@
           <a:chExt cx="0" cy="0"/>
         </a:xfrm>
       </p:grpSpPr>
-      <p:pic>
-        <p:nvPicPr>
-          <p:cNvPr id="108" name="Figure 1 DAG" descr="Directed acyclic graph of the assumed relationships between treatment, CRP, TMB/BRAF, age/sex and survival"/>
-          <p:cNvPicPr>
-            <a:picLocks noChangeAspect="1"/>
-          </p:cNvPicPr>
-          <p:nvPr/>
-        </p:nvPicPr>
-        <p:blipFill>
-          <a:blip r:embed="rId3"/>
-          <a:stretch>
-            <a:fillRect/>
-          </a:stretch>
-        </p:blipFill>
-        <p:spPr>
-          <a:xfrm>
-            <a:off x="2468880" y="19740592"/>
-            <a:ext cx="7863840" cy="5392347"/>
-          </a:xfrm>
-          <a:prstGeom prst="rect">
-            <a:avLst/>
-          </a:prstGeom>
-        </p:spPr>
-      </p:pic>
       <p:sp>
         <p:nvSpPr>
           <p:cNvPr id="101" name="Title box"/>
@@ -3507,17 +3483,21 @@
                 <a:latin typeface="Arial" panose="020B0604020202020204" pitchFamily="34" charset="0"/>
                 <a:cs typeface="Arial" panose="020B0604020202020204" pitchFamily="34" charset="0"/>
               </a:rPr>
-              <a:t>Biomarker signals in MSS/pMMR metastatic colorectal cancer (mCRC) are predominantly </a:t>
-            </a:r>
-          </a:p>
-          <a:p>
-            <a:pPr algn="ctr"/>
+              <a:t>Biomarker signals in MSS/pMMR metastatic colorectal cancer (mCRC) are predominantly prognostic, not predictive</a:t>
+            </a:r>
+          </a:p>
+          <a:p>
+            <a:pPr algn="ctr">
+              <a:spcAft>
+                <a:spcPts val="600"/>
+              </a:spcAft>
+            </a:pPr>
             <a:r>
               <a:rPr lang="en-US" sz="6000" b="1" dirty="0">
                 <a:latin typeface="Arial" panose="020B0604020202020204" pitchFamily="34" charset="0"/>
                 <a:cs typeface="Arial" panose="020B0604020202020204" pitchFamily="34" charset="0"/>
               </a:rPr>
-              <a:t>prognostic, not predictive – lessons from the randomized phase-2 METIMMOX trial</a:t>
+              <a:t>– lessons from the randomized phase-2 METIMMOX trial</a:t>
             </a:r>
           </a:p>
           <a:p>
@@ -3545,7 +3525,14 @@
                 <a:latin typeface="Arial" panose="020B0604020202020204" pitchFamily="34" charset="0"/>
                 <a:cs typeface="Arial" panose="020B0604020202020204" pitchFamily="34" charset="0"/>
               </a:rPr>
-              <a:t>, Megan Othus</a:t>
+              <a:t xml:space="preserve">, </a:t>
+            </a:r>
+            <a:r>
+              <a:rPr lang="en-US" sz="4400" dirty="0">
+                <a:latin typeface="Arial" panose="020B0604020202020204" pitchFamily="34" charset="0"/>
+                <a:cs typeface="Arial" panose="020B0604020202020204" pitchFamily="34" charset="0"/>
+              </a:rPr>
+              <a:t>Megan Othus</a:t>
             </a:r>
             <a:r>
               <a:rPr lang="en-US" sz="4400" baseline="30000" dirty="0">
@@ -3559,7 +3546,14 @@
                 <a:latin typeface="Arial" panose="020B0604020202020204" pitchFamily="34" charset="0"/>
                 <a:cs typeface="Arial" panose="020B0604020202020204" pitchFamily="34" charset="0"/>
               </a:rPr>
-              <a:t>, Sebastian Meltzer</a:t>
+              <a:t xml:space="preserve">, </a:t>
+            </a:r>
+            <a:r>
+              <a:rPr lang="en-US" sz="4400" dirty="0">
+                <a:latin typeface="Arial" panose="020B0604020202020204" pitchFamily="34" charset="0"/>
+                <a:cs typeface="Arial" panose="020B0604020202020204" pitchFamily="34" charset="0"/>
+              </a:rPr>
+              <a:t>Sebastian Meltzer</a:t>
             </a:r>
             <a:r>
               <a:rPr lang="en-US" sz="4400" baseline="30000" dirty="0">
@@ -3573,7 +3567,14 @@
                 <a:latin typeface="Arial" panose="020B0604020202020204" pitchFamily="34" charset="0"/>
                 <a:cs typeface="Arial" panose="020B0604020202020204" pitchFamily="34" charset="0"/>
               </a:rPr>
-              <a:t>, Paula A. Bousquet</a:t>
+              <a:t xml:space="preserve">, </a:t>
+            </a:r>
+            <a:r>
+              <a:rPr lang="en-US" sz="4400" dirty="0">
+                <a:latin typeface="Arial" panose="020B0604020202020204" pitchFamily="34" charset="0"/>
+                <a:cs typeface="Arial" panose="020B0604020202020204" pitchFamily="34" charset="0"/>
+              </a:rPr>
+              <a:t>Paula A. Bousquet</a:t>
             </a:r>
             <a:r>
               <a:rPr lang="en-US" sz="4400" baseline="30000" dirty="0">
@@ -3587,7 +3588,14 @@
                 <a:latin typeface="Arial" panose="020B0604020202020204" pitchFamily="34" charset="0"/>
                 <a:cs typeface="Arial" panose="020B0604020202020204" pitchFamily="34" charset="0"/>
               </a:rPr>
-              <a:t>, Emily A. Burger</a:t>
+              <a:t xml:space="preserve">, </a:t>
+            </a:r>
+            <a:r>
+              <a:rPr lang="en-US" sz="4400" dirty="0">
+                <a:latin typeface="Arial" panose="020B0604020202020204" pitchFamily="34" charset="0"/>
+                <a:cs typeface="Arial" panose="020B0604020202020204" pitchFamily="34" charset="0"/>
+              </a:rPr>
+              <a:t>Emily A. Burger</a:t>
             </a:r>
             <a:r>
               <a:rPr lang="en-US" sz="4400" baseline="30000" dirty="0">
@@ -3601,7 +3609,14 @@
                 <a:latin typeface="Arial" panose="020B0604020202020204" pitchFamily="34" charset="0"/>
                 <a:cs typeface="Arial" panose="020B0604020202020204" pitchFamily="34" charset="0"/>
               </a:rPr>
-              <a:t>, Eline Aas</a:t>
+              <a:t xml:space="preserve">, </a:t>
+            </a:r>
+            <a:r>
+              <a:rPr lang="en-US" sz="4400" dirty="0">
+                <a:latin typeface="Arial" panose="020B0604020202020204" pitchFamily="34" charset="0"/>
+                <a:cs typeface="Arial" panose="020B0604020202020204" pitchFamily="34" charset="0"/>
+              </a:rPr>
+              <a:t>Eline Aas</a:t>
             </a:r>
             <a:r>
               <a:rPr lang="en-US" sz="4400" baseline="30000" dirty="0">
@@ -3615,7 +3630,14 @@
                 <a:latin typeface="Arial" panose="020B0604020202020204" pitchFamily="34" charset="0"/>
                 <a:cs typeface="Arial" panose="020B0604020202020204" pitchFamily="34" charset="0"/>
               </a:rPr>
-              <a:t>, Anne H. Ree</a:t>
+              <a:t xml:space="preserve">, </a:t>
+            </a:r>
+            <a:r>
+              <a:rPr lang="en-US" sz="4400" dirty="0">
+                <a:latin typeface="Arial" panose="020B0604020202020204" pitchFamily="34" charset="0"/>
+                <a:cs typeface="Arial" panose="020B0604020202020204" pitchFamily="34" charset="0"/>
+              </a:rPr>
+              <a:t>Anne H. Ree</a:t>
             </a:r>
             <a:r>
               <a:rPr lang="en-US" sz="4400" baseline="30000" dirty="0">
@@ -3639,7 +3661,7 @@
                 <a:latin typeface="Arial" panose="020B0604020202020204" pitchFamily="34" charset="0"/>
                 <a:cs typeface="Arial" panose="020B0604020202020204" pitchFamily="34" charset="0"/>
               </a:rPr>
-              <a:t>Department of Health Management and Health Economics, University of Oslo, Oslo, Norway; </a:t>
+              <a:t xml:space="preserve">Department of Health Management and Health Economics, University of Oslo, Oslo, Norway; </a:t>
             </a:r>
             <a:r>
               <a:rPr lang="en-US" sz="3200" baseline="30000" dirty="0">
@@ -3653,7 +3675,7 @@
                 <a:latin typeface="Arial" panose="020B0604020202020204" pitchFamily="34" charset="0"/>
                 <a:cs typeface="Arial" panose="020B0604020202020204" pitchFamily="34" charset="0"/>
               </a:rPr>
-              <a:t>Department of Oncology, Akershus University Hospital, Lørenskog, Norway; </a:t>
+              <a:t xml:space="preserve">Department of Oncology, Akershus University Hospital, Lørenskog, Norway; </a:t>
             </a:r>
             <a:r>
               <a:rPr lang="en-US" sz="3200" baseline="30000" dirty="0">
@@ -3667,7 +3689,7 @@
                 <a:latin typeface="Arial" panose="020B0604020202020204" pitchFamily="34" charset="0"/>
                 <a:cs typeface="Arial" panose="020B0604020202020204" pitchFamily="34" charset="0"/>
               </a:rPr>
-              <a:t>Fred Hutchinson Cancer Center, Seattle WA, United States; </a:t>
+              <a:t xml:space="preserve">Fred Hutchinson Cancer Center, Seattle WA, United States; </a:t>
             </a:r>
             <a:r>
               <a:rPr lang="en-US" sz="3200" baseline="30000" dirty="0">
@@ -3681,7 +3703,7 @@
                 <a:latin typeface="Arial" panose="020B0604020202020204" pitchFamily="34" charset="0"/>
                 <a:cs typeface="Arial" panose="020B0604020202020204" pitchFamily="34" charset="0"/>
               </a:rPr>
-              <a:t>Center for Health Decision Science, Harvard T. H. Chan School of Public Health, Boston MA, United States; </a:t>
+              <a:t xml:space="preserve">Center for Health Decision Science, Harvard T. H. Chan School of Public Health, Boston MA, United States; </a:t>
             </a:r>
             <a:r>
               <a:rPr lang="en-US" sz="3200" baseline="30000" dirty="0">
@@ -3695,7 +3717,7 @@
                 <a:latin typeface="Arial" panose="020B0604020202020204" pitchFamily="34" charset="0"/>
                 <a:cs typeface="Arial" panose="020B0604020202020204" pitchFamily="34" charset="0"/>
               </a:rPr>
-              <a:t>Division for Health Services, Norwegian Institute of Public Health, Oslo, Norway; </a:t>
+              <a:t xml:space="preserve">Division for Health Services, Norwegian Institute of Public Health, Oslo, Norway; </a:t>
             </a:r>
             <a:r>
               <a:rPr lang="en-US" sz="3200" baseline="30000" dirty="0">
@@ -3755,7 +3777,7 @@
         </p:nvSpPr>
         <p:spPr>
           <a:xfrm>
-            <a:off x="316121" y="4471416"/>
+            <a:off x="283464" y="4471416"/>
             <a:ext cx="12188952" cy="987552"/>
           </a:xfrm>
           <a:prstGeom prst="roundRect">
@@ -3845,8 +3867,8 @@
         </p:nvSpPr>
         <p:spPr>
           <a:xfrm>
-            <a:off x="365760" y="5751575"/>
-            <a:ext cx="12106656" cy="4579441"/>
+            <a:off x="365760" y="5751576"/>
+            <a:ext cx="12106656" cy="4572000"/>
           </a:xfrm>
           <a:prstGeom prst="roundRect">
             <a:avLst/>
@@ -3893,6 +3915,7 @@
               <a:rPr lang="en-US" sz="3200" dirty="0"/>
               <a:t>Immune checkpoint blockade is ineffective in unselected MSS/pMMR mCRC.</a:t>
             </a:r>
+            <a:endParaRPr lang="en-US" sz="3200" dirty="0"/>
           </a:p>
           <a:p>
             <a:pPr marL="571500" indent="-571500">
@@ -3904,8 +3927,9 @@
             </a:pPr>
             <a:r>
               <a:rPr lang="en-US" sz="3200" dirty="0"/>
-              <a:t>METIMMOX (randomized phase 2; NCT03388190): alternating oxaliplatin-based chemotherapy (FLOX) + nivolumab vs FLOX alone; identical PFS.</a:t>
-            </a:r>
+              <a:t>METIMMOX (randomized phase 2; NCT03388190, EudraCT 2017-001845-29): alternating FLOX + nivolumab vs FLOX alone; identical progression-free survival (PFS).</a:t>
+            </a:r>
+            <a:endParaRPr lang="en-US" sz="3200" dirty="0"/>
           </a:p>
           <a:p>
             <a:pPr marL="571500" indent="-571500">
@@ -3927,6 +3951,7 @@
               <a:rPr lang="en-US" sz="3200" dirty="0"/>
               <a:t>, CRP, TLR) conflated prognostic and predictive effects; we separated them in one pre-specified interaction model per endpoint.</a:t>
             </a:r>
+            <a:endParaRPr lang="en-US" sz="3200" dirty="0"/>
           </a:p>
         </p:txBody>
       </p:sp>
@@ -3938,7 +3963,7 @@
         </p:nvSpPr>
         <p:spPr>
           <a:xfrm>
-            <a:off x="316121" y="10716372"/>
+            <a:off x="283464" y="10597896"/>
             <a:ext cx="12188952" cy="978408"/>
           </a:xfrm>
           <a:prstGeom prst="roundRect">
@@ -3983,8 +4008,8 @@
         </p:nvSpPr>
         <p:spPr>
           <a:xfrm>
-            <a:off x="329184" y="11964666"/>
-            <a:ext cx="12143232" cy="14089203"/>
+            <a:off x="329184" y="11832336"/>
+            <a:ext cx="12143232" cy="14548104"/>
           </a:xfrm>
           <a:prstGeom prst="roundRect">
             <a:avLst/>
@@ -4028,9 +4053,10 @@
               <a:buChar char="o"/>
             </a:pPr>
             <a:r>
-              <a:rPr lang="en-US" sz="3600" dirty="0"/>
-              <a:t>68 complete cases (59 deaths; 63 PFS events).</a:t>
-            </a:r>
+              <a:rPr lang="en-US" sz="3200" dirty="0"/>
+              <a:t>68 complete cases (59 deaths; 50 progression-or-death events; deaths &gt;16 weeks after the last scan censored for PFS).</a:t>
+            </a:r>
+            <a:endParaRPr lang="en-US" sz="3200" dirty="0"/>
           </a:p>
           <a:p>
             <a:pPr marL="571500" indent="-571500">
@@ -4041,17 +4067,18 @@
               <a:buChar char="o"/>
             </a:pPr>
             <a:r>
-              <a:rPr lang="en-US" sz="3600" dirty="0"/>
-              <a:t>Biomarkers before nivolumab: TMB ≥9 mut/Mb or </a:t>
-            </a:r>
-            <a:r>
-              <a:rPr lang="en-US" sz="3600" i="1" dirty="0"/>
+              <a:rPr lang="en-US" sz="3200" dirty="0"/>
+              <a:t xml:space="preserve">Biomarkers before nivolumab: TMB ≥9 mut/Mb or </a:t>
+            </a:r>
+            <a:r>
+              <a:rPr lang="en-US" sz="3200" i="1" dirty="0"/>
               <a:t>BRAF</a:t>
             </a:r>
             <a:r>
-              <a:rPr lang="en-US" sz="3600" dirty="0"/>
-              <a:t> V600E; CRP &lt;5 mg/L after 2 FLOX cycles common to both arms (by chance 47% vs 19% positive).</a:t>
-            </a:r>
+              <a:rPr lang="en-US" sz="3200" dirty="0"/>
+              <a:t xml:space="preserve"> V600E (baseline); CRP &lt;5 mg/L at week 4, after 2 FLOX cycles common to both arms (by chance 47% vs 19% positive).</a:t>
+            </a:r>
+            <a:endParaRPr lang="en-US" sz="3200" dirty="0"/>
           </a:p>
           <a:p>
             <a:pPr marL="571500" indent="-571500">
@@ -4062,9 +4089,10 @@
               <a:buChar char="o"/>
             </a:pPr>
             <a:r>
-              <a:rPr lang="en-US" sz="3600" dirty="0"/>
-              <a:t>TLR ≥10% at the first on-treatment CT: analyzed as intermediate endpoint with a week-9 landmark.</a:t>
-            </a:r>
+              <a:rPr lang="en-US" sz="3200" dirty="0"/>
+              <a:t>TLR ≥10% at the first on-treatment CT: intermediate endpoint (T → TLR → PFS), analyzed with a week-9 landmark.</a:t>
+            </a:r>
+            <a:endParaRPr lang="en-US" sz="3200" dirty="0"/>
           </a:p>
           <a:p>
             <a:pPr marL="571500" indent="-571500">
@@ -4075,17 +4103,18 @@
               <a:buChar char="o"/>
             </a:pPr>
             <a:r>
-              <a:rPr lang="en-US" sz="3600" dirty="0"/>
-              <a:t>Per endpoint (PFS, OS): one Firth-corrected Cox model with age, sex, treatment, biomarker main effects and treatment × biomarker interactions (</a:t>
-            </a:r>
-            <a:r>
-              <a:rPr lang="en-US" sz="3600" b="1" dirty="0"/>
+              <a:rPr lang="en-US" sz="3200" dirty="0"/>
+              <a:t>Per endpoint (PFS, overall survival [OS]): one Firth-corrected Cox model with age, sex, treatment, biomarker main effects and treatment × biomarker interactions (</a:t>
+            </a:r>
+            <a:r>
+              <a:rPr lang="en-US" sz="3200" b="1" dirty="0"/>
               <a:t>Figure 1</a:t>
             </a:r>
             <a:r>
-              <a:rPr lang="en-US" sz="3600" dirty="0"/>
-              <a:t>); profile-likelihood 95% CIs, PLRT.</a:t>
-            </a:r>
+              <a:rPr lang="en-US" sz="3200" dirty="0"/>
+              <a:t>); profile-likelihood 95% CIs, penalized likelihood-ratio tests (PLRT).</a:t>
+            </a:r>
+            <a:endParaRPr lang="en-US" sz="3200" dirty="0"/>
           </a:p>
           <a:p>
             <a:pPr marL="571500" indent="-571500">
@@ -4096,12 +4125,37 @@
               <a:buChar char="o"/>
             </a:pPr>
             <a:r>
-              <a:rPr lang="en-US" sz="3600" dirty="0"/>
-              <a:t>Ridge-penalized Cox as co-primary stability estimator.</a:t>
-            </a:r>
-          </a:p>
-        </p:txBody>
-      </p:sp>
+              <a:rPr lang="en-US" sz="3200" dirty="0"/>
+              <a:t>Stability check: ridge-penalized Cox shrinking the biomarker terms (cross-validated penalty).</a:t>
+            </a:r>
+            <a:endParaRPr lang="en-US" sz="3200" dirty="0"/>
+          </a:p>
+        </p:txBody>
+      </p:sp>
+      <p:pic>
+        <p:nvPicPr>
+          <p:cNvPr id="108" name="Figure 1 DAG" descr="Directed acyclic graph of the assumed relationships between treatment, CRP, TMB/BRAF, age/sex and survival"/>
+          <p:cNvPicPr>
+            <a:picLocks noChangeAspect="1"/>
+          </p:cNvPicPr>
+          <p:nvPr/>
+        </p:nvPicPr>
+        <p:blipFill>
+          <a:blip r:embed="rId7"/>
+          <a:stretch>
+            <a:fillRect/>
+          </a:stretch>
+        </p:blipFill>
+        <p:spPr>
+          <a:xfrm>
+            <a:off x="2468880" y="20165133"/>
+            <a:ext cx="7863840" cy="5392347"/>
+          </a:xfrm>
+          <a:prstGeom prst="rect">
+            <a:avLst/>
+          </a:prstGeom>
+        </p:spPr>
+      </p:pic>
       <p:sp>
         <p:nvSpPr>
           <p:cNvPr id="109" name="Figure 1 caption"/>
@@ -4110,7 +4164,7 @@
         </p:nvSpPr>
         <p:spPr>
           <a:xfrm>
-            <a:off x="822960" y="25132939"/>
+            <a:off x="822960" y="25557480"/>
             <a:ext cx="11155680" cy="777240"/>
           </a:xfrm>
           <a:prstGeom prst="rect">
@@ -4127,7 +4181,7 @@
             <a:pPr algn="ctr"/>
             <a:r>
               <a:rPr lang="en-US" sz="2400" b="1" dirty="0"/>
-              <a:t>Figure 1. Assumed relationships (DAG) behind the model. </a:t>
+              <a:t xml:space="preserve">Figure 1. Assumed relationships (DAG) behind the model. </a:t>
             </a:r>
             <a:r>
               <a:rPr lang="en-US" sz="2400" dirty="0"/>
@@ -4153,7 +4207,7 @@
           <p:nvPr/>
         </p:nvPicPr>
         <p:blipFill>
-          <a:blip r:embed="rId4"/>
+          <a:blip r:embed="rId5"/>
           <a:stretch>
             <a:fillRect/>
           </a:stretch>
@@ -4222,12 +4276,13 @@
             </a:pPr>
             <a:r>
               <a:rPr lang="en-US" sz="4000" b="1" dirty="0"/>
-              <a:t>No marginal treatment effect: </a:t>
+              <a:t xml:space="preserve">No marginal treatment effect: </a:t>
             </a:r>
             <a:r>
               <a:rPr lang="en-US" sz="4000" dirty="0"/>
-              <a:t>OS HR 0.96 (95% CI 0.58–1.61); PFS HR 0.80 (0.49–1.33).</a:t>
-            </a:r>
+              <a:t>OS HR 0.96 (95% CI 0.58–1.61); PFS HR 0.77 (0.44–1.38).</a:t>
+            </a:r>
+            <a:endParaRPr lang="en-US" sz="4000" dirty="0"/>
           </a:p>
           <a:p>
             <a:pPr marL="571500" indent="-571500">
@@ -4237,7 +4292,39 @@
               <a:buFont typeface="Courier New" panose="02070309020205020404" pitchFamily="49" charset="0"/>
               <a:buChar char="o"/>
             </a:pPr>
-            <a:endParaRPr lang="en-US" sz="2000" dirty="0"/>
+            <a:r>
+              <a:rPr lang="en-US" sz="4000" b="1" dirty="0"/>
+              <a:t xml:space="preserve">Prognostic: </a:t>
+            </a:r>
+            <a:r>
+              <a:rPr lang="en-US" sz="4000" dirty="0"/>
+              <a:t>CRP &lt;5 mg/L and TMB/</a:t>
+            </a:r>
+            <a:r>
+              <a:rPr lang="en-US" sz="4000" i="1" dirty="0"/>
+              <a:t>BRAF</a:t>
+            </a:r>
+            <a:r>
+              <a:rPr lang="en-US" sz="4000" dirty="0"/>
+              <a:t xml:space="preserve"> positivity were associated with longer PFS (HR 0.39 each) and, for CRP, longer OS (HR 0.49), regardless of treatment (</a:t>
+            </a:r>
+            <a:r>
+              <a:rPr lang="en-US" sz="4000" b="1" dirty="0"/>
+              <a:t>Table 1</a:t>
+            </a:r>
+            <a:r>
+              <a:rPr lang="en-US" sz="4000" dirty="0"/>
+              <a:t xml:space="preserve">, </a:t>
+            </a:r>
+            <a:r>
+              <a:rPr lang="en-US" sz="4000" b="1" dirty="0"/>
+              <a:t>Figure 2</a:t>
+            </a:r>
+            <a:r>
+              <a:rPr lang="en-US" sz="4000" dirty="0"/>
+              <a:t>).</a:t>
+            </a:r>
+            <a:endParaRPr lang="en-US" sz="4000" dirty="0"/>
           </a:p>
           <a:p>
             <a:pPr marL="571500" indent="-571500">
@@ -4249,58 +4336,7 @@
             </a:pPr>
             <a:r>
               <a:rPr lang="en-US" sz="4000" b="1" dirty="0"/>
-              <a:t>Prognostic: </a:t>
-            </a:r>
-            <a:r>
-              <a:rPr lang="en-US" sz="4000" dirty="0"/>
-              <a:t>CRP &lt;5 mg/L and TMB/</a:t>
-            </a:r>
-            <a:r>
-              <a:rPr lang="en-US" sz="4000" i="1" dirty="0"/>
-              <a:t>BRAF</a:t>
-            </a:r>
-            <a:r>
-              <a:rPr lang="en-US" sz="4000" dirty="0"/>
-              <a:t> positivity were associated with longer PFS (HR 0.41 and 0.49) and, for CRP, longer OS (HR 0.49), regardless of treatment (</a:t>
-            </a:r>
-            <a:r>
-              <a:rPr lang="en-US" sz="4000" b="1" dirty="0"/>
-              <a:t>Table 1</a:t>
-            </a:r>
-            <a:r>
-              <a:rPr lang="en-US" sz="4000" dirty="0"/>
-              <a:t>, </a:t>
-            </a:r>
-            <a:r>
-              <a:rPr lang="en-US" sz="4000" b="1" dirty="0"/>
-              <a:t>Figure 2</a:t>
-            </a:r>
-            <a:r>
-              <a:rPr lang="en-US" sz="4000" dirty="0"/>
-              <a:t>).</a:t>
-            </a:r>
-          </a:p>
-          <a:p>
-            <a:pPr marL="571500" indent="-571500">
-              <a:spcAft>
-                <a:spcPts val="1600"/>
-              </a:spcAft>
-              <a:buFont typeface="Courier New" panose="02070309020205020404" pitchFamily="49" charset="0"/>
-              <a:buChar char="o"/>
-            </a:pPr>
-            <a:endParaRPr lang="en-US" sz="2000" dirty="0"/>
-          </a:p>
-          <a:p>
-            <a:pPr marL="571500" indent="-571500">
-              <a:spcAft>
-                <a:spcPts val="1600"/>
-              </a:spcAft>
-              <a:buFont typeface="Courier New" panose="02070309020205020404" pitchFamily="49" charset="0"/>
-              <a:buChar char="o"/>
-            </a:pPr>
-            <a:r>
-              <a:rPr lang="en-US" sz="4000" b="1" dirty="0"/>
-              <a:t>Not predictive: </a:t>
+              <a:t xml:space="preserve">Not predictive: </a:t>
             </a:r>
             <a:r>
               <a:rPr lang="en-US" sz="4000" dirty="0"/>
@@ -4312,18 +4348,9 @@
             </a:r>
             <a:r>
               <a:rPr lang="en-US" sz="4000" dirty="0"/>
-              <a:t>). Most consistent signal: CRP × treatment for PFS, HR 0.42 (0.11–1.68), p = 0.21, ridge HR 0.33; attenuated for OS (HR 0.65).</a:t>
-            </a:r>
-          </a:p>
-          <a:p>
-            <a:pPr marL="571500" indent="-571500">
-              <a:spcAft>
-                <a:spcPts val="1600"/>
-              </a:spcAft>
-              <a:buFont typeface="Courier New" panose="02070309020205020404" pitchFamily="49" charset="0"/>
-              <a:buChar char="o"/>
-            </a:pPr>
-            <a:endParaRPr lang="en-US" sz="2000" dirty="0"/>
+              <a:t>). Largest signal: CRP × treatment for PFS, HR 0.26 (0.06–1.34), p = 0.10, but it shrinks toward 1 under ridge (HR 0.66) and is weaker for OS (HR 0.65).</a:t>
+            </a:r>
+            <a:endParaRPr lang="en-US" sz="4000" dirty="0"/>
           </a:p>
           <a:p>
             <a:pPr marL="571500" indent="-571500">
@@ -4335,27 +4362,13 @@
             </a:pPr>
             <a:r>
               <a:rPr lang="en-US" sz="4000" b="1" dirty="0"/>
-              <a:t>TLR: </a:t>
+              <a:t xml:space="preserve">TLR: </a:t>
             </a:r>
             <a:r>
               <a:rPr lang="en-US" sz="4000" dirty="0"/>
-              <a:t>strongly prognostic for both endpoints (landmark HR 0.35), but more frequent with FLOX alone (76% vs 53%) and with an interaction HR &gt;1</a:t>
-            </a:r>
-            <a:r>
-              <a:rPr lang="en-US" sz="4000"/>
-              <a:t>: </a:t>
-            </a:r>
-            <a:br>
-              <a:rPr lang="en-US" sz="4000"/>
-            </a:br>
-            <a:r>
-              <a:rPr lang="en-US" sz="4000"/>
-              <a:t>a </a:t>
-            </a:r>
-            <a:r>
-              <a:rPr lang="en-US" sz="4000" dirty="0"/>
-              <a:t>marker of chemotherapy-responsive disease, not of nivolumab benefit.</a:t>
-            </a:r>
+              <a:t>strongly prognostic (landmark HR 0.35 OS, 0.21 PFS), but more frequent with FLOX alone (76% vs 53%), with inconsistent interactions (HR 2.47 OS, 0.88 PFS): a marker of chemotherapy-responsive disease, not of nivolumab benefit.</a:t>
+            </a:r>
+            <a:endParaRPr lang="en-US" sz="4000" dirty="0"/>
           </a:p>
         </p:txBody>
       </p:sp>
@@ -4383,7 +4396,7 @@
           <a:p>
             <a:r>
               <a:rPr lang="en-US" sz="2800" b="1" dirty="0"/>
-              <a:t>Table 1. </a:t>
+              <a:t xml:space="preserve">Table 1. </a:t>
             </a:r>
             <a:r>
               <a:rPr lang="en-US" sz="2800" dirty="0"/>
@@ -4398,13 +4411,7 @@
           <p:cNvGraphicFramePr>
             <a:graphicFrameLocks noGrp="1"/>
           </p:cNvGraphicFramePr>
-          <p:nvPr>
-            <p:extLst>
-              <p:ext uri="{D42A27DB-BD31-4B8C-83A1-F6EECF244321}">
-                <p14:modId xmlns:p14="http://schemas.microsoft.com/office/powerpoint/2010/main" val="485809887"/>
-              </p:ext>
-            </p:extLst>
-          </p:nvPr>
+          <p:nvPr/>
         </p:nvGraphicFramePr>
         <p:xfrm>
           <a:off x="12929616" y="20487132"/>
@@ -4415,62 +4422,14 @@
             <a:tbl>
               <a:tblPr firstRow="1" bandRow="1"/>
               <a:tblGrid>
-                <a:gridCol w="6400800">
-                  <a:extLst>
-                    <a:ext uri="{9D8B030D-6E8A-4147-A177-3AD203B41FA5}">
-                      <a16:colId xmlns:a16="http://schemas.microsoft.com/office/drawing/2014/main" val="20000"/>
-                    </a:ext>
-                  </a:extLst>
-                </a:gridCol>
-                <a:gridCol w="5029200">
-                  <a:extLst>
-                    <a:ext uri="{9D8B030D-6E8A-4147-A177-3AD203B41FA5}">
-                      <a16:colId xmlns:a16="http://schemas.microsoft.com/office/drawing/2014/main" val="20001"/>
-                    </a:ext>
-                  </a:extLst>
-                </a:gridCol>
-                <a:gridCol w="3474720">
-                  <a:extLst>
-                    <a:ext uri="{9D8B030D-6E8A-4147-A177-3AD203B41FA5}">
-                      <a16:colId xmlns:a16="http://schemas.microsoft.com/office/drawing/2014/main" val="20002"/>
-                    </a:ext>
-                  </a:extLst>
-                </a:gridCol>
-                <a:gridCol w="1554480">
-                  <a:extLst>
-                    <a:ext uri="{9D8B030D-6E8A-4147-A177-3AD203B41FA5}">
-                      <a16:colId xmlns:a16="http://schemas.microsoft.com/office/drawing/2014/main" val="20003"/>
-                    </a:ext>
-                  </a:extLst>
-                </a:gridCol>
-                <a:gridCol w="2011680">
-                  <a:extLst>
-                    <a:ext uri="{9D8B030D-6E8A-4147-A177-3AD203B41FA5}">
-                      <a16:colId xmlns:a16="http://schemas.microsoft.com/office/drawing/2014/main" val="20004"/>
-                    </a:ext>
-                  </a:extLst>
-                </a:gridCol>
-                <a:gridCol w="3474720">
-                  <a:extLst>
-                    <a:ext uri="{9D8B030D-6E8A-4147-A177-3AD203B41FA5}">
-                      <a16:colId xmlns:a16="http://schemas.microsoft.com/office/drawing/2014/main" val="20005"/>
-                    </a:ext>
-                  </a:extLst>
-                </a:gridCol>
-                <a:gridCol w="1554480">
-                  <a:extLst>
-                    <a:ext uri="{9D8B030D-6E8A-4147-A177-3AD203B41FA5}">
-                      <a16:colId xmlns:a16="http://schemas.microsoft.com/office/drawing/2014/main" val="20006"/>
-                    </a:ext>
-                  </a:extLst>
-                </a:gridCol>
-                <a:gridCol w="2093976">
-                  <a:extLst>
-                    <a:ext uri="{9D8B030D-6E8A-4147-A177-3AD203B41FA5}">
-                      <a16:colId xmlns:a16="http://schemas.microsoft.com/office/drawing/2014/main" val="20007"/>
-                    </a:ext>
-                  </a:extLst>
-                </a:gridCol>
+                <a:gridCol w="6400800"/>
+                <a:gridCol w="5029200"/>
+                <a:gridCol w="3474720"/>
+                <a:gridCol w="1554480"/>
+                <a:gridCol w="2011680"/>
+                <a:gridCol w="3474720"/>
+                <a:gridCol w="1554480"/>
+                <a:gridCol w="2093976"/>
               </a:tblGrid>
               <a:tr h="530352">
                 <a:tc rowSpan="2">
@@ -4737,11 +4696,6 @@
                     </a:solidFill>
                   </a:tcPr>
                 </a:tc>
-                <a:extLst>
-                  <a:ext uri="{0D108BD9-81ED-4DB2-BD59-A6C34878D82A}">
-                    <a16:rowId xmlns:a16="http://schemas.microsoft.com/office/drawing/2014/main" val="10000"/>
-                  </a:ext>
-                </a:extLst>
               </a:tr>
               <a:tr h="530352">
                 <a:tc vMerge="1">
@@ -5016,11 +4970,6 @@
                     </a:solidFill>
                   </a:tcPr>
                 </a:tc>
-                <a:extLst>
-                  <a:ext uri="{0D108BD9-81ED-4DB2-BD59-A6C34878D82A}">
-                    <a16:rowId xmlns:a16="http://schemas.microsoft.com/office/drawing/2014/main" val="10001"/>
-                  </a:ext>
-                </a:extLst>
               </a:tr>
               <a:tr h="530352">
                 <a:tc>
@@ -5033,6 +4982,7 @@
                         <a:rPr lang="en-US" sz="2800" dirty="0"/>
                         <a:t>Treatment (FLOX/nivolumab vs FLOX)</a:t>
                       </a:r>
+                      <a:endParaRPr lang="en-US" sz="2800" dirty="0"/>
                     </a:p>
                   </a:txBody>
                   <a:tcPr marL="60000" marR="60000" marT="18000" marB="18000" anchor="ctr">
@@ -5061,6 +5011,7 @@
                         <a:rPr lang="en-US" sz="2800" dirty="0"/>
                         <a:t>Univariable</a:t>
                       </a:r>
+                      <a:endParaRPr lang="en-US" sz="2800" dirty="0"/>
                     </a:p>
                   </a:txBody>
                   <a:tcPr marL="60000" marR="60000" marT="18000" marB="18000" anchor="ctr">
@@ -5089,6 +5040,7 @@
                         <a:rPr lang="en-US" sz="2800" dirty="0"/>
                         <a:t>0.96 (0.58–1.61)</a:t>
                       </a:r>
+                      <a:endParaRPr lang="en-US" sz="2800" dirty="0"/>
                     </a:p>
                   </a:txBody>
                   <a:tcPr marL="60000" marR="60000" marT="18000" marB="18000" anchor="ctr">
@@ -5098,14 +5050,8 @@
                     <a:lnR>
                       <a:noFill/>
                     </a:lnR>
-                    <a:lnT w="12700" cap="flat" cmpd="sng" algn="ctr">
-                      <a:solidFill>
-                        <a:srgbClr val="000000"/>
-                      </a:solidFill>
-                      <a:prstDash val="solid"/>
-                      <a:round/>
-                      <a:headEnd type="none" w="med" len="med"/>
-                      <a:tailEnd type="none" w="med" len="med"/>
+                    <a:lnT>
+                      <a:noFill/>
                     </a:lnT>
                     <a:lnB>
                       <a:noFill/>
@@ -5123,6 +5069,7 @@
                         <a:rPr lang="en-US" sz="2800" dirty="0"/>
                         <a:t>0.87</a:t>
                       </a:r>
+                      <a:endParaRPr lang="en-US" sz="2800" dirty="0"/>
                     </a:p>
                   </a:txBody>
                   <a:tcPr marL="60000" marR="60000" marT="18000" marB="18000" anchor="ctr">
@@ -5132,14 +5079,8 @@
                     <a:lnR>
                       <a:noFill/>
                     </a:lnR>
-                    <a:lnT w="12700" cap="flat" cmpd="sng" algn="ctr">
-                      <a:solidFill>
-                        <a:srgbClr val="000000"/>
-                      </a:solidFill>
-                      <a:prstDash val="solid"/>
-                      <a:round/>
-                      <a:headEnd type="none" w="med" len="med"/>
-                      <a:tailEnd type="none" w="med" len="med"/>
+                    <a:lnT>
+                      <a:noFill/>
                     </a:lnT>
                     <a:lnB>
                       <a:noFill/>
@@ -5157,6 +5098,7 @@
                         <a:rPr lang="en-US" sz="2800" dirty="0"/>
                         <a:t>–</a:t>
                       </a:r>
+                      <a:endParaRPr lang="en-US" sz="2800" dirty="0"/>
                     </a:p>
                   </a:txBody>
                   <a:tcPr marL="60000" marR="60000" marT="18000" marB="18000" anchor="ctr">
@@ -5166,14 +5108,8 @@
                     <a:lnR>
                       <a:noFill/>
                     </a:lnR>
-                    <a:lnT w="12700" cap="flat" cmpd="sng" algn="ctr">
-                      <a:solidFill>
-                        <a:srgbClr val="000000"/>
-                      </a:solidFill>
-                      <a:prstDash val="solid"/>
-                      <a:round/>
-                      <a:headEnd type="none" w="med" len="med"/>
-                      <a:tailEnd type="none" w="med" len="med"/>
+                    <a:lnT>
+                      <a:noFill/>
                     </a:lnT>
                     <a:lnB>
                       <a:noFill/>
@@ -5189,8 +5125,9 @@
                       <a:pPr algn="ctr"/>
                       <a:r>
                         <a:rPr lang="en-US" sz="2800" dirty="0"/>
-                        <a:t>0.80 (0.49–1.33)</a:t>
+                        <a:t>0.77 (0.44–1.38)</a:t>
                       </a:r>
+                      <a:endParaRPr lang="en-US" sz="2800" dirty="0"/>
                     </a:p>
                   </a:txBody>
                   <a:tcPr marL="60000" marR="60000" marT="18000" marB="18000" anchor="ctr">
@@ -5200,14 +5137,8 @@
                     <a:lnR>
                       <a:noFill/>
                     </a:lnR>
-                    <a:lnT w="12700" cap="flat" cmpd="sng" algn="ctr">
-                      <a:solidFill>
-                        <a:srgbClr val="000000"/>
-                      </a:solidFill>
-                      <a:prstDash val="solid"/>
-                      <a:round/>
-                      <a:headEnd type="none" w="med" len="med"/>
-                      <a:tailEnd type="none" w="med" len="med"/>
+                    <a:lnT>
+                      <a:noFill/>
                     </a:lnT>
                     <a:lnB>
                       <a:noFill/>
@@ -5223,8 +5154,9 @@
                       <a:pPr algn="ctr"/>
                       <a:r>
                         <a:rPr lang="en-US" sz="2800" dirty="0"/>
-                        <a:t>0.39</a:t>
+                        <a:t>0.38</a:t>
                       </a:r>
+                      <a:endParaRPr lang="en-US" sz="2800" dirty="0"/>
                     </a:p>
                   </a:txBody>
                   <a:tcPr marL="60000" marR="60000" marT="18000" marB="18000" anchor="ctr">
@@ -5234,14 +5166,8 @@
                     <a:lnR>
                       <a:noFill/>
                     </a:lnR>
-                    <a:lnT w="12700" cap="flat" cmpd="sng" algn="ctr">
-                      <a:solidFill>
-                        <a:srgbClr val="000000"/>
-                      </a:solidFill>
-                      <a:prstDash val="solid"/>
-                      <a:round/>
-                      <a:headEnd type="none" w="med" len="med"/>
-                      <a:tailEnd type="none" w="med" len="med"/>
+                    <a:lnT>
+                      <a:noFill/>
                     </a:lnT>
                     <a:lnB>
                       <a:noFill/>
@@ -5259,6 +5185,7 @@
                         <a:rPr lang="en-US" sz="2800" dirty="0"/>
                         <a:t>–</a:t>
                       </a:r>
+                      <a:endParaRPr lang="en-US" sz="2800" dirty="0"/>
                     </a:p>
                   </a:txBody>
                   <a:tcPr marL="60000" marR="60000" marT="18000" marB="18000" anchor="ctr">
@@ -5268,14 +5195,8 @@
                     <a:lnR>
                       <a:noFill/>
                     </a:lnR>
-                    <a:lnT w="12700" cap="flat" cmpd="sng" algn="ctr">
-                      <a:solidFill>
-                        <a:srgbClr val="000000"/>
-                      </a:solidFill>
-                      <a:prstDash val="solid"/>
-                      <a:round/>
-                      <a:headEnd type="none" w="med" len="med"/>
-                      <a:tailEnd type="none" w="med" len="med"/>
+                    <a:lnT>
+                      <a:noFill/>
                     </a:lnT>
                     <a:lnB>
                       <a:noFill/>
@@ -5283,11 +5204,6 @@
                     <a:noFill/>
                   </a:tcPr>
                 </a:tc>
-                <a:extLst>
-                  <a:ext uri="{0D108BD9-81ED-4DB2-BD59-A6C34878D82A}">
-                    <a16:rowId xmlns:a16="http://schemas.microsoft.com/office/drawing/2014/main" val="10002"/>
-                  </a:ext>
-                </a:extLst>
               </a:tr>
               <a:tr h="530352">
                 <a:tc>
@@ -5300,6 +5216,7 @@
                         <a:rPr lang="en-US" sz="2800" dirty="0"/>
                         <a:t>CRP &lt;5 mg/L at week 4</a:t>
                       </a:r>
+                      <a:endParaRPr lang="en-US" sz="2800" dirty="0"/>
                     </a:p>
                   </a:txBody>
                   <a:tcPr marL="60000" marR="60000" marT="18000" marB="18000" anchor="ctr">
@@ -5328,6 +5245,7 @@
                         <a:rPr lang="en-US" sz="2800" dirty="0"/>
                         <a:t>Univariable (prognostic)</a:t>
                       </a:r>
+                      <a:endParaRPr lang="en-US" sz="2800" dirty="0"/>
                     </a:p>
                   </a:txBody>
                   <a:tcPr marL="60000" marR="60000" marT="18000" marB="18000" anchor="ctr">
@@ -5356,6 +5274,7 @@
                         <a:rPr lang="en-US" sz="2800" dirty="0"/>
                         <a:t>0.49 (0.27–0.84)</a:t>
                       </a:r>
+                      <a:endParaRPr lang="en-US" sz="2800" dirty="0"/>
                     </a:p>
                   </a:txBody>
                   <a:tcPr marL="60000" marR="60000" marT="18000" marB="18000" anchor="ctr">
@@ -5384,6 +5303,7 @@
                         <a:rPr lang="en-US" sz="2800" dirty="0"/>
                         <a:t>0.009</a:t>
                       </a:r>
+                      <a:endParaRPr lang="en-US" sz="2800" dirty="0"/>
                     </a:p>
                   </a:txBody>
                   <a:tcPr marL="60000" marR="60000" marT="18000" marB="18000" anchor="ctr">
@@ -5412,6 +5332,7 @@
                         <a:rPr lang="en-US" sz="2800" dirty="0"/>
                         <a:t>–</a:t>
                       </a:r>
+                      <a:endParaRPr lang="en-US" sz="2800" dirty="0"/>
                     </a:p>
                   </a:txBody>
                   <a:tcPr marL="60000" marR="60000" marT="18000" marB="18000" anchor="ctr">
@@ -5438,8 +5359,9 @@
                       <a:pPr algn="ctr"/>
                       <a:r>
                         <a:rPr lang="en-US" sz="2800" dirty="0"/>
-                        <a:t>0.41 (0.23–0.71)</a:t>
+                        <a:t>0.39 (0.20–0.73)</a:t>
                       </a:r>
+                      <a:endParaRPr lang="en-US" sz="2800" dirty="0"/>
                     </a:p>
                   </a:txBody>
                   <a:tcPr marL="60000" marR="60000" marT="18000" marB="18000" anchor="ctr">
@@ -5466,8 +5388,9 @@
                       <a:pPr algn="ctr"/>
                       <a:r>
                         <a:rPr lang="en-US" sz="2800" dirty="0"/>
-                        <a:t>0.001</a:t>
+                        <a:t>0.003</a:t>
                       </a:r>
+                      <a:endParaRPr lang="en-US" sz="2800" dirty="0"/>
                     </a:p>
                   </a:txBody>
                   <a:tcPr marL="60000" marR="60000" marT="18000" marB="18000" anchor="ctr">
@@ -5496,6 +5419,7 @@
                         <a:rPr lang="en-US" sz="2800" dirty="0"/>
                         <a:t>–</a:t>
                       </a:r>
+                      <a:endParaRPr lang="en-US" sz="2800" dirty="0"/>
                     </a:p>
                   </a:txBody>
                   <a:tcPr marL="60000" marR="60000" marT="18000" marB="18000" anchor="ctr">
@@ -5514,11 +5438,6 @@
                     <a:noFill/>
                   </a:tcPr>
                 </a:tc>
-                <a:extLst>
-                  <a:ext uri="{0D108BD9-81ED-4DB2-BD59-A6C34878D82A}">
-                    <a16:rowId xmlns:a16="http://schemas.microsoft.com/office/drawing/2014/main" val="10003"/>
-                  </a:ext>
-                </a:extLst>
               </a:tr>
               <a:tr h="530352">
                 <a:tc>
@@ -5529,7 +5448,7 @@
                       <a:pPr algn="l"/>
                       <a:r>
                         <a:rPr lang="en-US" sz="2800" dirty="0"/>
-                        <a:t>TMB ≥9 mut/Mb or </a:t>
+                        <a:t xml:space="preserve">TMB ≥9 mut/Mb or </a:t>
                       </a:r>
                       <a:r>
                         <a:rPr lang="en-US" sz="2800" i="1" dirty="0"/>
@@ -5537,8 +5456,9 @@
                       </a:r>
                       <a:r>
                         <a:rPr lang="en-US" sz="2800" dirty="0"/>
-                        <a:t> V600E</a:t>
+                        <a:t xml:space="preserve"> V600E</a:t>
                       </a:r>
+                      <a:endParaRPr lang="en-US" sz="2800" dirty="0"/>
                     </a:p>
                   </a:txBody>
                   <a:tcPr marL="60000" marR="60000" marT="18000" marB="18000" anchor="ctr">
@@ -5567,6 +5487,7 @@
                         <a:rPr lang="en-US" sz="2800" dirty="0"/>
                         <a:t>Univariable (prognostic)</a:t>
                       </a:r>
+                      <a:endParaRPr lang="en-US" sz="2800" dirty="0"/>
                     </a:p>
                   </a:txBody>
                   <a:tcPr marL="60000" marR="60000" marT="18000" marB="18000" anchor="ctr">
@@ -5595,6 +5516,7 @@
                         <a:rPr lang="en-US" sz="2800" dirty="0"/>
                         <a:t>0.68 (0.40–1.13)</a:t>
                       </a:r>
+                      <a:endParaRPr lang="en-US" sz="2800" dirty="0"/>
                     </a:p>
                   </a:txBody>
                   <a:tcPr marL="60000" marR="60000" marT="18000" marB="18000" anchor="ctr">
@@ -5623,6 +5545,7 @@
                         <a:rPr lang="en-US" sz="2800" dirty="0"/>
                         <a:t>0.14</a:t>
                       </a:r>
+                      <a:endParaRPr lang="en-US" sz="2800" dirty="0"/>
                     </a:p>
                   </a:txBody>
                   <a:tcPr marL="60000" marR="60000" marT="18000" marB="18000" anchor="ctr">
@@ -5651,6 +5574,7 @@
                         <a:rPr lang="en-US" sz="2800" dirty="0"/>
                         <a:t>–</a:t>
                       </a:r>
+                      <a:endParaRPr lang="en-US" sz="2800" dirty="0"/>
                     </a:p>
                   </a:txBody>
                   <a:tcPr marL="60000" marR="60000" marT="18000" marB="18000" anchor="ctr">
@@ -5677,8 +5601,9 @@
                       <a:pPr algn="ctr"/>
                       <a:r>
                         <a:rPr lang="en-US" sz="2800" dirty="0"/>
-                        <a:t>0.49 (0.28–0.84)</a:t>
+                        <a:t>0.39 (0.21–0.73)</a:t>
                       </a:r>
+                      <a:endParaRPr lang="en-US" sz="2800" dirty="0"/>
                     </a:p>
                   </a:txBody>
                   <a:tcPr marL="60000" marR="60000" marT="18000" marB="18000" anchor="ctr">
@@ -5705,8 +5630,9 @@
                       <a:pPr algn="ctr"/>
                       <a:r>
                         <a:rPr lang="en-US" sz="2800" dirty="0"/>
-                        <a:t>0.009</a:t>
+                        <a:t>0.003</a:t>
                       </a:r>
+                      <a:endParaRPr lang="en-US" sz="2800" dirty="0"/>
                     </a:p>
                   </a:txBody>
                   <a:tcPr marL="60000" marR="60000" marT="18000" marB="18000" anchor="ctr">
@@ -5735,6 +5661,7 @@
                         <a:rPr lang="en-US" sz="2800" dirty="0"/>
                         <a:t>–</a:t>
                       </a:r>
+                      <a:endParaRPr lang="en-US" sz="2800" dirty="0"/>
                     </a:p>
                   </a:txBody>
                   <a:tcPr marL="60000" marR="60000" marT="18000" marB="18000" anchor="ctr">
@@ -5753,11 +5680,6 @@
                     <a:noFill/>
                   </a:tcPr>
                 </a:tc>
-                <a:extLst>
-                  <a:ext uri="{0D108BD9-81ED-4DB2-BD59-A6C34878D82A}">
-                    <a16:rowId xmlns:a16="http://schemas.microsoft.com/office/drawing/2014/main" val="10004"/>
-                  </a:ext>
-                </a:extLst>
               </a:tr>
               <a:tr h="530352">
                 <a:tc>
@@ -5770,6 +5692,7 @@
                         <a:rPr lang="en-US" sz="2800" dirty="0"/>
                         <a:t>TLR ≥10% (week-9 landmark)†</a:t>
                       </a:r>
+                      <a:endParaRPr lang="en-US" sz="2800" dirty="0"/>
                     </a:p>
                   </a:txBody>
                   <a:tcPr marL="60000" marR="60000" marT="18000" marB="18000" anchor="ctr">
@@ -5798,6 +5721,7 @@
                         <a:rPr lang="en-US" sz="2800" dirty="0"/>
                         <a:t>Univariable (prognostic)</a:t>
                       </a:r>
+                      <a:endParaRPr lang="en-US" sz="2800" dirty="0"/>
                     </a:p>
                   </a:txBody>
                   <a:tcPr marL="60000" marR="60000" marT="18000" marB="18000" anchor="ctr">
@@ -5826,6 +5750,7 @@
                         <a:rPr lang="en-US" sz="2800" dirty="0"/>
                         <a:t>0.35 (0.21–0.61)</a:t>
                       </a:r>
+                      <a:endParaRPr lang="en-US" sz="2800" dirty="0"/>
                     </a:p>
                   </a:txBody>
                   <a:tcPr marL="60000" marR="60000" marT="18000" marB="18000" anchor="ctr">
@@ -5854,6 +5779,7 @@
                         <a:rPr lang="en-US" sz="2800" dirty="0"/>
                         <a:t>&lt;0.001</a:t>
                       </a:r>
+                      <a:endParaRPr lang="en-US" sz="2800" dirty="0"/>
                     </a:p>
                   </a:txBody>
                   <a:tcPr marL="60000" marR="60000" marT="18000" marB="18000" anchor="ctr">
@@ -5882,6 +5808,7 @@
                         <a:rPr lang="en-US" sz="2800" dirty="0"/>
                         <a:t>–</a:t>
                       </a:r>
+                      <a:endParaRPr lang="en-US" sz="2800" dirty="0"/>
                     </a:p>
                   </a:txBody>
                   <a:tcPr marL="60000" marR="60000" marT="18000" marB="18000" anchor="ctr">
@@ -5908,8 +5835,9 @@
                       <a:pPr algn="ctr"/>
                       <a:r>
                         <a:rPr lang="en-US" sz="2800" dirty="0"/>
-                        <a:t>0.35 (0.20–0.63)</a:t>
+                        <a:t>0.21 (0.11–0.42)</a:t>
                       </a:r>
+                      <a:endParaRPr lang="en-US" sz="2800" dirty="0"/>
                     </a:p>
                   </a:txBody>
                   <a:tcPr marL="60000" marR="60000" marT="18000" marB="18000" anchor="ctr">
@@ -5938,6 +5866,7 @@
                         <a:rPr lang="en-US" sz="2800" dirty="0"/>
                         <a:t>&lt;0.001</a:t>
                       </a:r>
+                      <a:endParaRPr lang="en-US" sz="2800" dirty="0"/>
                     </a:p>
                   </a:txBody>
                   <a:tcPr marL="60000" marR="60000" marT="18000" marB="18000" anchor="ctr">
@@ -5966,6 +5895,7 @@
                         <a:rPr lang="en-US" sz="2800" dirty="0"/>
                         <a:t>–</a:t>
                       </a:r>
+                      <a:endParaRPr lang="en-US" sz="2800" dirty="0"/>
                     </a:p>
                   </a:txBody>
                   <a:tcPr marL="60000" marR="60000" marT="18000" marB="18000" anchor="ctr">
@@ -5984,11 +5914,6 @@
                     <a:noFill/>
                   </a:tcPr>
                 </a:tc>
-                <a:extLst>
-                  <a:ext uri="{0D108BD9-81ED-4DB2-BD59-A6C34878D82A}">
-                    <a16:rowId xmlns:a16="http://schemas.microsoft.com/office/drawing/2014/main" val="10005"/>
-                  </a:ext>
-                </a:extLst>
               </a:tr>
               <a:tr h="530352">
                 <a:tc>
@@ -6001,6 +5926,7 @@
                         <a:rPr lang="en-US" sz="2800" dirty="0"/>
                         <a:t>CRP × treatment</a:t>
                       </a:r>
+                      <a:endParaRPr lang="en-US" sz="2800" dirty="0"/>
                     </a:p>
                   </a:txBody>
                   <a:tcPr marL="60000" marR="60000" marT="18000" marB="18000" anchor="ctr">
@@ -6029,6 +5955,7 @@
                         <a:rPr lang="en-US" sz="2800" dirty="0"/>
                         <a:t>Unified interaction model</a:t>
                       </a:r>
+                      <a:endParaRPr lang="en-US" sz="2800" dirty="0"/>
                     </a:p>
                   </a:txBody>
                   <a:tcPr marL="60000" marR="60000" marT="18000" marB="18000" anchor="ctr">
@@ -6057,6 +5984,7 @@
                         <a:rPr lang="en-US" sz="2800" dirty="0"/>
                         <a:t>0.65 (0.19–2.60)</a:t>
                       </a:r>
+                      <a:endParaRPr lang="en-US" sz="2800" dirty="0"/>
                     </a:p>
                   </a:txBody>
                   <a:tcPr marL="60000" marR="60000" marT="18000" marB="18000" anchor="ctr">
@@ -6085,6 +6013,7 @@
                         <a:rPr lang="en-US" sz="2800" dirty="0"/>
                         <a:t>0.52</a:t>
                       </a:r>
+                      <a:endParaRPr lang="en-US" sz="2800" dirty="0"/>
                     </a:p>
                   </a:txBody>
                   <a:tcPr marL="60000" marR="60000" marT="18000" marB="18000" anchor="ctr">
@@ -6111,8 +6040,9 @@
                       <a:pPr algn="ctr"/>
                       <a:r>
                         <a:rPr lang="en-US" sz="2800" dirty="0"/>
-                        <a:t>0.40</a:t>
+                        <a:t>0.80</a:t>
                       </a:r>
+                      <a:endParaRPr lang="en-US" sz="2800" dirty="0"/>
                     </a:p>
                   </a:txBody>
                   <a:tcPr marL="60000" marR="60000" marT="18000" marB="18000" anchor="ctr">
@@ -6139,8 +6069,9 @@
                       <a:pPr algn="ctr"/>
                       <a:r>
                         <a:rPr lang="en-US" sz="2800" dirty="0"/>
-                        <a:t>0.42 (0.11–1.68)</a:t>
+                        <a:t>0.26 (0.06–1.34)</a:t>
                       </a:r>
+                      <a:endParaRPr lang="en-US" sz="2800" dirty="0"/>
                     </a:p>
                   </a:txBody>
                   <a:tcPr marL="60000" marR="60000" marT="18000" marB="18000" anchor="ctr">
@@ -6167,8 +6098,9 @@
                       <a:pPr algn="ctr"/>
                       <a:r>
                         <a:rPr lang="en-US" sz="2800" dirty="0"/>
-                        <a:t>0.21</a:t>
+                        <a:t>0.10</a:t>
                       </a:r>
+                      <a:endParaRPr lang="en-US" sz="2800" dirty="0"/>
                     </a:p>
                   </a:txBody>
                   <a:tcPr marL="60000" marR="60000" marT="18000" marB="18000" anchor="ctr">
@@ -6195,8 +6127,9 @@
                       <a:pPr algn="ctr"/>
                       <a:r>
                         <a:rPr lang="en-US" sz="2800" dirty="0"/>
-                        <a:t>0.33</a:t>
+                        <a:t>0.66</a:t>
                       </a:r>
+                      <a:endParaRPr lang="en-US" sz="2800" dirty="0"/>
                     </a:p>
                   </a:txBody>
                   <a:tcPr marL="60000" marR="60000" marT="18000" marB="18000" anchor="ctr">
@@ -6215,11 +6148,6 @@
                     <a:noFill/>
                   </a:tcPr>
                 </a:tc>
-                <a:extLst>
-                  <a:ext uri="{0D108BD9-81ED-4DB2-BD59-A6C34878D82A}">
-                    <a16:rowId xmlns:a16="http://schemas.microsoft.com/office/drawing/2014/main" val="10006"/>
-                  </a:ext>
-                </a:extLst>
               </a:tr>
               <a:tr h="530352">
                 <a:tc>
@@ -6238,8 +6166,9 @@
                       </a:r>
                       <a:r>
                         <a:rPr lang="en-US" sz="2800" dirty="0"/>
-                        <a:t> × treatment</a:t>
+                        <a:t xml:space="preserve"> × treatment</a:t>
                       </a:r>
+                      <a:endParaRPr lang="en-US" sz="2800" dirty="0"/>
                     </a:p>
                   </a:txBody>
                   <a:tcPr marL="60000" marR="60000" marT="18000" marB="18000" anchor="ctr">
@@ -6268,6 +6197,7 @@
                         <a:rPr lang="en-US" sz="2800" dirty="0"/>
                         <a:t>Unified interaction model</a:t>
                       </a:r>
+                      <a:endParaRPr lang="en-US" sz="2800" dirty="0"/>
                     </a:p>
                   </a:txBody>
                   <a:tcPr marL="60000" marR="60000" marT="18000" marB="18000" anchor="ctr">
@@ -6296,6 +6226,7 @@
                         <a:rPr lang="en-US" sz="2800" dirty="0"/>
                         <a:t>0.95 (0.32–2.82)</a:t>
                       </a:r>
+                      <a:endParaRPr lang="en-US" sz="2800" dirty="0"/>
                     </a:p>
                   </a:txBody>
                   <a:tcPr marL="60000" marR="60000" marT="18000" marB="18000" anchor="ctr">
@@ -6324,6 +6255,7 @@
                         <a:rPr lang="en-US" sz="2800" dirty="0"/>
                         <a:t>0.92</a:t>
                       </a:r>
+                      <a:endParaRPr lang="en-US" sz="2800" dirty="0"/>
                     </a:p>
                   </a:txBody>
                   <a:tcPr marL="60000" marR="60000" marT="18000" marB="18000" anchor="ctr">
@@ -6350,8 +6282,9 @@
                       <a:pPr algn="ctr"/>
                       <a:r>
                         <a:rPr lang="en-US" sz="2800" dirty="0"/>
-                        <a:t>0.86</a:t>
+                        <a:t>0.91</a:t>
                       </a:r>
+                      <a:endParaRPr lang="en-US" sz="2800" dirty="0"/>
                     </a:p>
                   </a:txBody>
                   <a:tcPr marL="60000" marR="60000" marT="18000" marB="18000" anchor="ctr">
@@ -6378,8 +6311,9 @@
                       <a:pPr algn="ctr"/>
                       <a:r>
                         <a:rPr lang="en-US" sz="2800" dirty="0"/>
-                        <a:t>0.66 (0.21–2.05)</a:t>
+                        <a:t>0.65 (0.18–2.41)</a:t>
                       </a:r>
+                      <a:endParaRPr lang="en-US" sz="2800" dirty="0"/>
                     </a:p>
                   </a:txBody>
                   <a:tcPr marL="60000" marR="60000" marT="18000" marB="18000" anchor="ctr">
@@ -6406,8 +6340,9 @@
                       <a:pPr algn="ctr"/>
                       <a:r>
                         <a:rPr lang="en-US" sz="2800" dirty="0"/>
-                        <a:t>0.47</a:t>
+                        <a:t>0.52</a:t>
                       </a:r>
+                      <a:endParaRPr lang="en-US" sz="2800" dirty="0"/>
                     </a:p>
                   </a:txBody>
                   <a:tcPr marL="60000" marR="60000" marT="18000" marB="18000" anchor="ctr">
@@ -6434,8 +6369,9 @@
                       <a:pPr algn="ctr"/>
                       <a:r>
                         <a:rPr lang="en-US" sz="2800" dirty="0"/>
-                        <a:t>0.51</a:t>
+                        <a:t>0.74</a:t>
                       </a:r>
+                      <a:endParaRPr lang="en-US" sz="2800" dirty="0"/>
                     </a:p>
                   </a:txBody>
                   <a:tcPr marL="60000" marR="60000" marT="18000" marB="18000" anchor="ctr">
@@ -6454,11 +6390,6 @@
                     <a:noFill/>
                   </a:tcPr>
                 </a:tc>
-                <a:extLst>
-                  <a:ext uri="{0D108BD9-81ED-4DB2-BD59-A6C34878D82A}">
-                    <a16:rowId xmlns:a16="http://schemas.microsoft.com/office/drawing/2014/main" val="10007"/>
-                  </a:ext>
-                </a:extLst>
               </a:tr>
               <a:tr h="530352">
                 <a:tc>
@@ -6471,6 +6402,7 @@
                         <a:rPr lang="en-US" sz="2800" dirty="0"/>
                         <a:t>TLR × treatment</a:t>
                       </a:r>
+                      <a:endParaRPr lang="en-US" sz="2800" dirty="0"/>
                     </a:p>
                   </a:txBody>
                   <a:tcPr marL="60000" marR="60000" marT="18000" marB="18000" anchor="ctr">
@@ -6503,6 +6435,7 @@
                         <a:rPr lang="en-US" sz="2800" dirty="0"/>
                         <a:t>Landmark responder model†</a:t>
                       </a:r>
+                      <a:endParaRPr lang="en-US" sz="2800" dirty="0"/>
                     </a:p>
                   </a:txBody>
                   <a:tcPr marL="60000" marR="60000" marT="18000" marB="18000" anchor="ctr">
@@ -6535,6 +6468,7 @@
                         <a:rPr lang="en-US" sz="2800" dirty="0"/>
                         <a:t>2.47 (0.75–7.75)</a:t>
                       </a:r>
+                      <a:endParaRPr lang="en-US" sz="2800" dirty="0"/>
                     </a:p>
                   </a:txBody>
                   <a:tcPr marL="60000" marR="60000" marT="18000" marB="18000" anchor="ctr">
@@ -6567,6 +6501,7 @@
                         <a:rPr lang="en-US" sz="2800" dirty="0"/>
                         <a:t>0.14</a:t>
                       </a:r>
+                      <a:endParaRPr lang="en-US" sz="2800" dirty="0"/>
                     </a:p>
                   </a:txBody>
                   <a:tcPr marL="60000" marR="60000" marT="18000" marB="18000" anchor="ctr">
@@ -6597,8 +6532,9 @@
                       <a:pPr algn="ctr"/>
                       <a:r>
                         <a:rPr lang="en-US" sz="2800" dirty="0"/>
-                        <a:t>–</a:t>
+                        <a:t>1.13‡</a:t>
                       </a:r>
+                      <a:endParaRPr lang="en-US" sz="2800" dirty="0"/>
                     </a:p>
                   </a:txBody>
                   <a:tcPr marL="60000" marR="60000" marT="18000" marB="18000" anchor="ctr">
@@ -6629,8 +6565,9 @@
                       <a:pPr algn="ctr"/>
                       <a:r>
                         <a:rPr lang="en-US" sz="2800" dirty="0"/>
-                        <a:t>1.88 (0.52–6.38)</a:t>
+                        <a:t>0.88 (0.21–3.38)</a:t>
                       </a:r>
+                      <a:endParaRPr lang="en-US" sz="2800" dirty="0"/>
                     </a:p>
                   </a:txBody>
                   <a:tcPr marL="60000" marR="60000" marT="18000" marB="18000" anchor="ctr">
@@ -6661,8 +6598,9 @@
                       <a:pPr algn="ctr"/>
                       <a:r>
                         <a:rPr lang="en-US" sz="2800" dirty="0"/>
-                        <a:t>0.33</a:t>
+                        <a:t>0.85</a:t>
                       </a:r>
+                      <a:endParaRPr lang="en-US" sz="2800" dirty="0"/>
                     </a:p>
                   </a:txBody>
                   <a:tcPr marL="60000" marR="60000" marT="18000" marB="18000" anchor="ctr">
@@ -6693,8 +6631,9 @@
                       <a:pPr algn="ctr"/>
                       <a:r>
                         <a:rPr lang="en-US" sz="2800" dirty="0"/>
-                        <a:t>–</a:t>
+                        <a:t>0.63</a:t>
                       </a:r>
+                      <a:endParaRPr lang="en-US" sz="2800" dirty="0"/>
                     </a:p>
                   </a:txBody>
                   <a:tcPr marL="60000" marR="60000" marT="18000" marB="18000" anchor="ctr">
@@ -6717,11 +6656,6 @@
                     <a:noFill/>
                   </a:tcPr>
                 </a:tc>
-                <a:extLst>
-                  <a:ext uri="{0D108BD9-81ED-4DB2-BD59-A6C34878D82A}">
-                    <a16:rowId xmlns:a16="http://schemas.microsoft.com/office/drawing/2014/main" val="10008"/>
-                  </a:ext>
-                </a:extLst>
               </a:tr>
             </a:tbl>
           </a:graphicData>
@@ -6767,58 +6701,96 @@
           </a:fontRef>
         </p:style>
         <p:txBody>
-          <a:bodyPr lIns="109728" tIns="36576" rIns="109728" bIns="36576" rtlCol="0" anchor="ctr">
+          <a:bodyPr lIns="109728" rIns="109728" tIns="36576" bIns="36576" rtlCol="0" anchor="ctr">
             <a:noAutofit/>
           </a:bodyPr>
           <a:lstStyle/>
           <a:p>
             <a:r>
-              <a:rPr lang="en-US" sz="2400" dirty="0"/>
-              <a:t>n = 68; p = PLRT. </a:t>
-            </a:r>
-            <a:r>
-              <a:rPr lang="en-US" sz="2400" b="1" dirty="0"/>
-              <a:t>Unified model: </a:t>
-            </a:r>
-            <a:r>
-              <a:rPr lang="en-US" sz="2400" dirty="0"/>
+              <a:rPr lang="en-US" sz="2200" dirty="0"/>
+              <a:t xml:space="preserve">n = 68; p = penalized likelihood-ratio test. </a:t>
+            </a:r>
+            <a:r>
+              <a:rPr lang="en-US" sz="2200" b="1" dirty="0"/>
+              <a:t xml:space="preserve">Unified model: </a:t>
+            </a:r>
+            <a:r>
+              <a:rPr lang="en-US" sz="2200" dirty="0"/>
               <a:t>age + sex + treatment + CRP + TMB/</a:t>
             </a:r>
             <a:r>
-              <a:rPr lang="en-US" sz="2400" i="1" dirty="0"/>
+              <a:rPr lang="en-US" sz="2200" i="1" dirty="0"/>
               <a:t>BRAF</a:t>
             </a:r>
             <a:r>
-              <a:rPr lang="en-US" sz="2400" dirty="0"/>
-              <a:t> + both treatment × biomarker interactions. </a:t>
-            </a:r>
-            <a:r>
-              <a:rPr lang="en-US" sz="2400" b="1" dirty="0"/>
-              <a:t>Ridge: </a:t>
-            </a:r>
-            <a:r>
-              <a:rPr lang="en-US" sz="2400" dirty="0"/>
-              <a:t>L2-penalized Cox, point estimates. </a:t>
-            </a:r>
-            <a:br>
-              <a:rPr lang="en-US" sz="2400" dirty="0"/>
-            </a:br>
-            <a:r>
-              <a:rPr lang="en-US" sz="2400" b="1" dirty="0"/>
+              <a:rPr lang="en-US" sz="2200" dirty="0"/>
+              <a:t xml:space="preserve"> + both treatment × biomarker interactions. </a:t>
+            </a:r>
+            <a:r>
+              <a:rPr lang="en-US" sz="2200" b="1" dirty="0"/>
+              <a:t xml:space="preserve">Ridge: </a:t>
+            </a:r>
+            <a:r>
+              <a:rPr lang="en-US" sz="2200" dirty="0"/>
+              <a:t xml:space="preserve">L2-penalized Cox with cross-validated penalty on the biomarker (or TLR) main effects and interactions; point estimates. </a:t>
+            </a:r>
+            <a:r>
+              <a:rPr lang="en-US" sz="2200" b="1" dirty="0"/>
               <a:t>†</a:t>
             </a:r>
             <a:r>
-              <a:rPr lang="en-US" sz="2400" dirty="0"/>
-              <a:t>Week-9 landmark, TLR-classified patients (n = 65 OS, 60 PFS); the responder model adjusts for age, sex, CRP and TMB/</a:t>
-            </a:r>
-            <a:r>
-              <a:rPr lang="en-US" sz="2400" i="1" dirty="0"/>
+              <a:rPr lang="en-US" sz="2200" dirty="0"/>
+              <a:t>Week-9 landmark, TLR-classified patients (n = 65 OS, 56 PFS); the responder model adjusts for age, sex, CRP and TMB/</a:t>
+            </a:r>
+            <a:r>
+              <a:rPr lang="en-US" sz="2200" i="1" dirty="0"/>
               <a:t>BRAF</a:t>
             </a:r>
             <a:r>
-              <a:rPr lang="en-US" sz="2400" dirty="0"/>
-              <a:t>; TLR is measured on treatment, so this is not a treatment-selection estimate.</a:t>
-            </a:r>
+              <a:rPr lang="en-US" sz="2200" dirty="0"/>
+              <a:t xml:space="preserve">; TLR is measured on treatment, so this is not a treatment-selection estimate. </a:t>
+            </a:r>
+            <a:r>
+              <a:rPr lang="en-US" sz="2200" b="1" dirty="0"/>
+              <a:t>‡</a:t>
+            </a:r>
+            <a:r>
+              <a:rPr lang="en-US" sz="2200" dirty="0"/>
+              <a:t xml:space="preserve">0.92–1.80 across cross-validation splits. </a:t>
+            </a:r>
+            <a:r>
+              <a:rPr lang="en-US" sz="2200" b="1" dirty="0"/>
+              <a:t>CI</a:t>
+            </a:r>
+            <a:r>
+              <a:rPr lang="en-US" sz="2200" dirty="0"/>
+              <a:t xml:space="preserve">, confidence interval; </a:t>
+            </a:r>
+            <a:r>
+              <a:rPr lang="en-US" sz="2200" b="1" dirty="0"/>
+              <a:t>HR</a:t>
+            </a:r>
+            <a:r>
+              <a:rPr lang="en-US" sz="2200" dirty="0"/>
+              <a:t xml:space="preserve">, hazard ratio; </a:t>
+            </a:r>
+            <a:r>
+              <a:rPr lang="en-US" sz="2200" b="1" dirty="0"/>
+              <a:t>TLR</a:t>
+            </a:r>
+            <a:r>
+              <a:rPr lang="en-US" sz="2200" dirty="0"/>
+              <a:t xml:space="preserve">, target lesion reduction; </a:t>
+            </a:r>
+            <a:r>
+              <a:rPr lang="en-US" sz="2200" b="1" dirty="0"/>
+              <a:t>TMB</a:t>
+            </a:r>
+            <a:r>
+              <a:rPr lang="en-US" sz="2200" dirty="0"/>
+              <a:t>, tumor mutational burden.</a:t>
+            </a:r>
+            <a:endParaRPr lang="en-US" sz="2200" dirty="0"/>
           </a:p>
         </p:txBody>
       </p:sp>
@@ -6831,7 +6803,7 @@
           <p:nvPr/>
         </p:nvPicPr>
         <p:blipFill>
-          <a:blip r:embed="rId5"/>
+          <a:blip r:embed="rId6"/>
           <a:stretch>
             <a:fillRect/>
           </a:stretch>
@@ -6854,8 +6826,8 @@
         </p:nvSpPr>
         <p:spPr>
           <a:xfrm>
-            <a:off x="12931775" y="26654760"/>
-            <a:ext cx="37936297" cy="1046989"/>
+            <a:off x="365760" y="26654760"/>
+            <a:ext cx="50502312" cy="868680"/>
           </a:xfrm>
           <a:prstGeom prst="roundRect">
             <a:avLst/>
@@ -6878,7 +6850,7 @@
           <a:p>
             <a:pPr algn="ctr"/>
             <a:r>
-              <a:rPr lang="en-US" sz="6600" b="1" dirty="0">
+              <a:rPr lang="en-US" sz="5400" b="1" dirty="0">
                 <a:solidFill>
                   <a:prstClr val="white"/>
                 </a:solidFill>
@@ -6899,8 +6871,8 @@
         </p:nvSpPr>
         <p:spPr>
           <a:xfrm>
-            <a:off x="12931776" y="27961047"/>
-            <a:ext cx="37936296" cy="1744676"/>
+            <a:off x="365760" y="27706320"/>
+            <a:ext cx="50502312" cy="2011680"/>
           </a:xfrm>
           <a:prstGeom prst="roundRect">
             <a:avLst/>
@@ -6939,14 +6911,7 @@
             <a:pPr algn="ctr"/>
             <a:r>
               <a:rPr lang="en-US" sz="4400" b="1" dirty="0"/>
-              <a:t>In this exploratory analysis, biomarker signals in MSS/pMMR mCRC were predominantly prognostic rather than predictive. </a:t>
-            </a:r>
-          </a:p>
-          <a:p>
-            <a:pPr algn="ctr"/>
-            <a:r>
-              <a:rPr lang="en-US" sz="4400" b="1" dirty="0"/>
-              <a:t>The CRP × treatment interaction for PFS is hypothesis-generating, and evaluation in adequately powered prospective studies could be considered.</a:t>
+              <a:t>In this exploratory analysis, biomarker signals in MSS/pMMR mCRC were predominantly prognostic rather than predictive. The CRP × treatment interaction for PFS is hypothesis-generating and warrants evaluation in adequately powered prospective studies.</a:t>
             </a:r>
           </a:p>
         </p:txBody>
@@ -6960,7 +6925,7 @@
           <p:nvPr/>
         </p:nvPicPr>
         <p:blipFill>
-          <a:blip r:embed="rId6"/>
+          <a:blip r:embed="rId4"/>
           <a:srcRect b="50329"/>
           <a:stretch>
             <a:fillRect/>
@@ -7000,19 +6965,19 @@
           <a:p>
             <a:r>
               <a:rPr lang="en-US" sz="2400" b="1" dirty="0"/>
-              <a:t>Disclosure: </a:t>
+              <a:t xml:space="preserve">Disclosure: </a:t>
             </a:r>
             <a:r>
               <a:rPr lang="en-US" sz="2400" dirty="0"/>
-              <a:t>B.P. Geisler has no potential conflicts of interest to declare. </a:t>
+              <a:t xml:space="preserve">B.P. Geisler has no potential conflicts of interest to declare. </a:t>
             </a:r>
             <a:r>
               <a:rPr lang="en-US" sz="2400" b="1" dirty="0"/>
-              <a:t>Funding: </a:t>
+              <a:t xml:space="preserve">Funding: </a:t>
             </a:r>
             <a:r>
               <a:rPr lang="en-US" sz="2400" dirty="0"/>
-              <a:t>Study sponsored by Horizon Europe (101094938; ASCERTAIN project, www.access2meds.eu), Research Council of Norway (296114), Norwegian Cancer Society (215613 and 245151), South-Eastern Regional Health Authority (2018054), and Bristol-Myers Squibb and Sigma2 AS (in-kind donations). Views and opinions expressed are, however, those of the authors only and do not necessarily reflect those of the European Union or the European Health and Digital Executive Agency (HaDEA).</a:t>
+              <a:t>Study sponsored by European Union, Research Council of Norway, Norwegian Cancer Society, South-Eastern Regional Health Authority, and Bristol-Myers Squibb and Sigma2 AS (in-kind donations). Views and opinions expressed are, however, those of the authors only and do not necessarily reflect those of the European Union or the European Health and Digital Executive Agency (HaDEA).</a:t>
             </a:r>
           </a:p>
         </p:txBody>
@@ -7041,7 +7006,7 @@
           <a:p>
             <a:r>
               <a:rPr lang="en-US" sz="4400" b="1" baseline="30000" dirty="0"/>
-              <a:t>@ </a:t>
+              <a:t xml:space="preserve">@ </a:t>
             </a:r>
             <a:r>
               <a:rPr lang="en-US" sz="4400" b="1" dirty="0"/>
@@ -7059,7 +7024,7 @@
           <p:nvPr/>
         </p:nvPicPr>
         <p:blipFill>
-          <a:blip r:embed="rId7"/>
+          <a:blip r:embed="rId3"/>
           <a:stretch>
             <a:fillRect/>
           </a:stretch>
@@ -7074,170 +7039,6 @@
           </a:prstGeom>
         </p:spPr>
       </p:pic>
-      <p:sp>
-        <p:nvSpPr>
-          <p:cNvPr id="3" name="Methods header">
-            <a:extLst>
-              <a:ext uri="{FF2B5EF4-FFF2-40B4-BE49-F238E27FC236}">
-                <a16:creationId xmlns:a16="http://schemas.microsoft.com/office/drawing/2014/main" id="{5A6E1F6F-0F4A-7E1A-3A27-3D274F09E741}"/>
-              </a:ext>
-            </a:extLst>
-          </p:cNvPr>
-          <p:cNvSpPr/>
-          <p:nvPr/>
-        </p:nvSpPr>
-        <p:spPr>
-          <a:xfrm>
-            <a:off x="365760" y="26692641"/>
-            <a:ext cx="12139313" cy="1047516"/>
-          </a:xfrm>
-          <a:prstGeom prst="roundRect">
-            <a:avLst/>
-          </a:prstGeom>
-          <a:solidFill>
-            <a:srgbClr val="0093C8"/>
-          </a:solidFill>
-          <a:ln w="12700" cap="flat" cmpd="sng" algn="ctr">
-            <a:solidFill>
-              <a:srgbClr val="0093C8"/>
-            </a:solidFill>
-            <a:prstDash val="solid"/>
-            <a:miter lim="800000"/>
-          </a:ln>
-          <a:effectLst/>
-        </p:spPr>
-        <p:txBody>
-          <a:bodyPr rtlCol="0" anchor="ctr"/>
-          <a:lstStyle/>
-          <a:p>
-            <a:pPr algn="ctr"/>
-            <a:r>
-              <a:rPr lang="en-US" sz="5400" b="1" dirty="0">
-                <a:solidFill>
-                  <a:prstClr val="white"/>
-                </a:solidFill>
-                <a:latin typeface="Calibri" panose="020F0502020204030204"/>
-              </a:rPr>
-              <a:t>Abbreviations</a:t>
-            </a:r>
-            <a:endParaRPr lang="en-US" sz="5400" b="1" dirty="0">
-              <a:solidFill>
-                <a:prstClr val="white"/>
-              </a:solidFill>
-              <a:latin typeface="Calibri" panose="020F0502020204030204"/>
-              <a:ea typeface="+mn-ea"/>
-              <a:cs typeface="+mn-cs"/>
-            </a:endParaRPr>
-          </a:p>
-        </p:txBody>
-      </p:sp>
-      <p:sp>
-        <p:nvSpPr>
-          <p:cNvPr id="4" name="Background box">
-            <a:extLst>
-              <a:ext uri="{FF2B5EF4-FFF2-40B4-BE49-F238E27FC236}">
-                <a16:creationId xmlns:a16="http://schemas.microsoft.com/office/drawing/2014/main" id="{62E96ED5-270A-4981-6405-CC98BDB881C6}"/>
-              </a:ext>
-            </a:extLst>
-          </p:cNvPr>
-          <p:cNvSpPr/>
-          <p:nvPr/>
-        </p:nvSpPr>
-        <p:spPr>
-          <a:xfrm>
-            <a:off x="329183" y="27949161"/>
-            <a:ext cx="12178729" cy="1756562"/>
-          </a:xfrm>
-          <a:prstGeom prst="roundRect">
-            <a:avLst/>
-          </a:prstGeom>
-          <a:solidFill>
-            <a:schemeClr val="lt1">
-              <a:alpha val="0"/>
-            </a:schemeClr>
-          </a:solidFill>
-          <a:ln w="28575">
-            <a:solidFill>
-              <a:srgbClr val="0093C8"/>
-            </a:solidFill>
-          </a:ln>
-        </p:spPr>
-        <p:style>
-          <a:lnRef idx="2">
-            <a:schemeClr val="accent1"/>
-          </a:lnRef>
-          <a:fillRef idx="1">
-            <a:schemeClr val="lt1"/>
-          </a:fillRef>
-          <a:effectRef idx="0">
-            <a:schemeClr val="accent1"/>
-          </a:effectRef>
-          <a:fontRef idx="minor">
-            <a:schemeClr val="dk1"/>
-          </a:fontRef>
-        </p:style>
-        <p:txBody>
-          <a:bodyPr rtlCol="0" anchor="ctr">
-            <a:noAutofit/>
-          </a:bodyPr>
-          <a:lstStyle/>
-          <a:p>
-            <a:pPr>
-              <a:spcAft>
-                <a:spcPts val="1200"/>
-              </a:spcAft>
-            </a:pPr>
-            <a:r>
-              <a:rPr lang="en-US" sz="3200" b="1" dirty="0"/>
-              <a:t>CRP</a:t>
-            </a:r>
-            <a:r>
-              <a:rPr lang="en-US" sz="3200" dirty="0"/>
-              <a:t>: C-reactive protein – </a:t>
-            </a:r>
-            <a:r>
-              <a:rPr lang="en-US" sz="3200" b="1" dirty="0"/>
-              <a:t>OS</a:t>
-            </a:r>
-            <a:r>
-              <a:rPr lang="en-US" sz="3200" dirty="0"/>
-              <a:t>: overall survival – </a:t>
-            </a:r>
-            <a:r>
-              <a:rPr lang="en-US" sz="3200" b="1" dirty="0"/>
-              <a:t>PFS</a:t>
-            </a:r>
-            <a:r>
-              <a:rPr lang="en-US" sz="3200" dirty="0"/>
-              <a:t>: progression-free survival – </a:t>
-            </a:r>
-            <a:r>
-              <a:rPr lang="en-US" sz="3200" b="1" dirty="0"/>
-              <a:t>PLRT</a:t>
-            </a:r>
-            <a:r>
-              <a:rPr lang="en-US" sz="3200" dirty="0"/>
-              <a:t>: penalized likelihood-ratio tests – </a:t>
-            </a:r>
-            <a:r>
-              <a:rPr lang="en-US" sz="3200" b="1" dirty="0"/>
-              <a:t>TLR</a:t>
-            </a:r>
-            <a:r>
-              <a:rPr lang="en-US" sz="3200" dirty="0"/>
-              <a:t>: target lesion reduction – </a:t>
-            </a:r>
-            <a:r>
-              <a:rPr lang="en-US" sz="3200" b="1" dirty="0"/>
-              <a:t>TMB</a:t>
-            </a:r>
-            <a:r>
-              <a:rPr lang="en-US" sz="3200" dirty="0"/>
-              <a:t>: tumor mutational burden</a:t>
-            </a:r>
-          </a:p>
-        </p:txBody>
-      </p:sp>
     </p:spTree>
   </p:cSld>
   <p:clrMapOvr>

</xml_diff>